<commit_message>
Paper deck: drop the Esmer step from slide 2, notes and study page
Co-Authored-By: Claude Opus 5.5 <noreply@anthropic.com>
Claude-Session: https://claude.ai/code/session_01UiTC1BeuJK5BZLbarMcqjw
</commit_message>
<xml_diff>
--- a/deck/moshe_paper_icrnna.pptx
+++ b/deck/moshe_paper_icrnna.pptx
@@ -2456,7 +2456,7 @@
           <a:p>
             <a:r>
               <a:rPr lang="en-US" dirty="0"/>
-              <a:t>Why this paper? Because our detector is built on it. Esmer re-implemented it, and our code comes from that version. The paper makes three claims. The best accuracy on RML2016.10a, 63.24 percent. A small model: 0.79 million numbers to learn. And it says it is especially good at low SNR.</a:t>
+              <a:t>Why this paper? Because our detector is built on it. The paper makes three claims. The best accuracy on RML2016.10a, 63.24 percent. A small model: 0.79 million numbers to learn. And it says it is especially good at low SNR.</a:t>
             </a:r>
             <a:endParaRPr lang="en-US" dirty="0"/>
           </a:p>
@@ -8819,7 +8819,7 @@
                           <a:ea typeface="Calibri" pitchFamily="34" charset="-122"/>
                           <a:cs typeface="Calibri" pitchFamily="34" charset="-120"/>
                         </a:rPr>
-                        <a:t>ICRNNA (Esmer's version)</a:t>
+                        <a:t>ICRNNA (our version)</a:t>
                       </a:r>
                       <a:endParaRPr lang="en-US" sz="2200" dirty="0">
                         <a:latin typeface="Calibri" charset="0"/>
@@ -10404,97 +10404,6 @@
             </a:avLst>
           </a:prstGeom>
           <a:solidFill>
-            <a:srgbClr val="EEF2F6"/>
-          </a:solidFill>
-          <a:ln w="12700">
-            <a:solidFill>
-              <a:srgbClr val="EEF2F6"/>
-            </a:solidFill>
-            <a:prstDash val="solid"/>
-          </a:ln>
-        </p:spPr>
-      </p:sp>
-      <p:sp>
-        <p:nvSpPr>
-          <p:cNvPr id="8" name="Text 6"/>
-          <p:cNvSpPr txBox="1"/>
-          <p:nvPr/>
-        </p:nvSpPr>
-        <p:spPr>
-          <a:xfrm>
-            <a:off x="4343400" y="1463040"/>
-            <a:ext cx="3246120" cy="822960"/>
-          </a:xfrm>
-          <a:prstGeom prst="rect">
-            <a:avLst/>
-          </a:prstGeom>
-          <a:noFill/>
-          <a:ln/>
-        </p:spPr>
-        <p:txBody>
-          <a:bodyPr wrap="square" lIns="0" tIns="0" rIns="0" bIns="0" rtlCol="0" anchor="ctr"/>
-          <a:lstStyle/>
-          <a:p>
-            <a:pPr algn="ctr" indent="0" marL="0">
-              <a:buNone/>
-            </a:pPr>
-            <a:r>
-              <a:rPr lang="en-US" sz="2200" b="1" dirty="0">
-                <a:solidFill>
-                  <a:srgbClr val="1E293B"/>
-                </a:solidFill>
-                <a:latin typeface="Calibri" pitchFamily="34" charset="0"/>
-                <a:ea typeface="Calibri" pitchFamily="34" charset="-122"/>
-                <a:cs typeface="Calibri" pitchFamily="34" charset="-120"/>
-              </a:rPr>
-              <a:t>Esmer's version</a:t>
-            </a:r>
-            <a:endParaRPr lang="en-US" sz="2200" dirty="0"/>
-          </a:p>
-        </p:txBody>
-      </p:sp>
-      <p:sp>
-        <p:nvSpPr>
-          <p:cNvPr id="9" name="Shape 7"/>
-          <p:cNvSpPr/>
-          <p:nvPr/>
-        </p:nvSpPr>
-        <p:spPr>
-          <a:xfrm>
-            <a:off x="7635240" y="1691640"/>
-            <a:ext cx="457200" cy="384048"/>
-          </a:xfrm>
-          <a:prstGeom prst="rightArrow">
-            <a:avLst/>
-          </a:prstGeom>
-          <a:solidFill>
-            <a:srgbClr val="F08A24"/>
-          </a:solidFill>
-          <a:ln w="12700">
-            <a:solidFill>
-              <a:srgbClr val="F08A24"/>
-            </a:solidFill>
-            <a:prstDash val="solid"/>
-          </a:ln>
-        </p:spPr>
-      </p:sp>
-      <p:sp>
-        <p:nvSpPr>
-          <p:cNvPr id="10" name="Shape 8"/>
-          <p:cNvSpPr/>
-          <p:nvPr/>
-        </p:nvSpPr>
-        <p:spPr>
-          <a:xfrm>
-            <a:off x="8138160" y="1463040"/>
-            <a:ext cx="3246120" cy="822960"/>
-          </a:xfrm>
-          <a:prstGeom prst="roundRect">
-            <a:avLst>
-              <a:gd name="adj" fmla="val 13333"/>
-            </a:avLst>
-          </a:prstGeom>
-          <a:solidFill>
             <a:srgbClr val="0F1B2D"/>
           </a:solidFill>
           <a:ln w="12700">
@@ -10507,13 +10416,13 @@
       </p:sp>
       <p:sp>
         <p:nvSpPr>
-          <p:cNvPr id="11" name="Text 9"/>
-          <p:cNvSpPr txBox="1"/>
-          <p:nvPr/>
-        </p:nvSpPr>
-        <p:spPr>
-          <a:xfrm>
-            <a:off x="8138160" y="1463040"/>
+          <p:cNvPr id="8" name="Text 6"/>
+          <p:cNvSpPr txBox="1"/>
+          <p:nvPr/>
+        </p:nvSpPr>
+        <p:spPr>
+          <a:xfrm>
+            <a:off x="4343400" y="1463040"/>
             <a:ext cx="3246120" cy="822960"/>
           </a:xfrm>
           <a:prstGeom prst="rect">
@@ -10546,7 +10455,7 @@
       </p:sp>
       <p:sp>
         <p:nvSpPr>
-          <p:cNvPr id="12" name="Shape 10"/>
+          <p:cNvPr id="9" name="Shape 7"/>
           <p:cNvSpPr/>
           <p:nvPr/>
         </p:nvSpPr>
@@ -10573,7 +10482,7 @@
       </p:sp>
       <p:sp>
         <p:nvSpPr>
-          <p:cNvPr id="13" name="Text 11"/>
+          <p:cNvPr id="10" name="Text 8"/>
           <p:cNvSpPr txBox="1"/>
           <p:nvPr/>
         </p:nvSpPr>
@@ -10612,7 +10521,7 @@
       </p:sp>
       <p:sp>
         <p:nvSpPr>
-          <p:cNvPr id="14" name="Text 12"/>
+          <p:cNvPr id="11" name="Text 9"/>
           <p:cNvSpPr txBox="1"/>
           <p:nvPr/>
         </p:nvSpPr>
@@ -10651,7 +10560,7 @@
       </p:sp>
       <p:sp>
         <p:nvSpPr>
-          <p:cNvPr id="15" name="Shape 13"/>
+          <p:cNvPr id="12" name="Shape 10"/>
           <p:cNvSpPr/>
           <p:nvPr/>
         </p:nvSpPr>
@@ -10678,7 +10587,7 @@
       </p:sp>
       <p:sp>
         <p:nvSpPr>
-          <p:cNvPr id="16" name="Text 14"/>
+          <p:cNvPr id="13" name="Text 11"/>
           <p:cNvSpPr txBox="1"/>
           <p:nvPr/>
         </p:nvSpPr>
@@ -10717,7 +10626,7 @@
       </p:sp>
       <p:sp>
         <p:nvSpPr>
-          <p:cNvPr id="17" name="Text 15"/>
+          <p:cNvPr id="14" name="Text 12"/>
           <p:cNvSpPr txBox="1"/>
           <p:nvPr/>
         </p:nvSpPr>
@@ -10756,7 +10665,7 @@
       </p:sp>
       <p:sp>
         <p:nvSpPr>
-          <p:cNvPr id="18" name="Shape 16"/>
+          <p:cNvPr id="15" name="Shape 13"/>
           <p:cNvSpPr/>
           <p:nvPr/>
         </p:nvSpPr>
@@ -10783,7 +10692,7 @@
       </p:sp>
       <p:sp>
         <p:nvSpPr>
-          <p:cNvPr id="19" name="Text 17"/>
+          <p:cNvPr id="16" name="Text 14"/>
           <p:cNvSpPr txBox="1"/>
           <p:nvPr/>
         </p:nvSpPr>
@@ -10822,7 +10731,7 @@
       </p:sp>
       <p:sp>
         <p:nvSpPr>
-          <p:cNvPr id="20" name="Text 18"/>
+          <p:cNvPr id="17" name="Text 15"/>
           <p:cNvSpPr txBox="1"/>
           <p:nvPr/>
         </p:nvSpPr>
@@ -10861,7 +10770,7 @@
       </p:sp>
       <p:sp>
         <p:nvSpPr>
-          <p:cNvPr id="21" name="Text 19"/>
+          <p:cNvPr id="18" name="Text 16"/>
           <p:cNvSpPr txBox="1"/>
           <p:nvPr/>
         </p:nvSpPr>
@@ -10900,7 +10809,7 @@
       </p:sp>
       <p:sp>
         <p:nvSpPr>
-          <p:cNvPr id="23" name="Text 20"/>
+          <p:cNvPr id="20" name="Text 17"/>
           <p:cNvSpPr txBox="1"/>
           <p:nvPr/>
         </p:nvSpPr>

</xml_diff>

<commit_message>
First run of the authors' own code: 62.71% against the paper's 63.24
official_icrnna_2016_results.json: seed 0 of colab/official_icrnna_2016.py,
their code at ac000a0 unmodified, one fixed split (b86f4de2f128). Early
stop at epoch 61, best 55, validation accuracy 63.60 at the restored epoch
(paper: 63.59 at 58). Half a point from one run is within run-to-run
variation; seeds 1 and 2 are running.

The file is re-serialized from the Drive copy; it reproduces the recorded
accuracy from its confusion matrices and is byte-identical in size.

Paper deck slide 10 and its notes now read the result (notes may depend
on the runs); study page and Q&A updated; OFFICIAL_CODE.md and CLAUDE.md
record the run.

Co-Authored-By: Claude Opus 5.5 <noreply@anthropic.com>
Claude-Session: https://claude.ai/code/session_01UiTC1BeuJK5BZLbarMcqjw
</commit_message>
<xml_diff>
--- a/deck/moshe_paper_icrnna.pptx
+++ b/deck/moshe_paper_icrnna.pptx
@@ -1581,7 +1581,7 @@
           <a:p>
             <a:r>
               <a:rPr lang="en-US" dirty="0"/>
-              <a:t>The paper came out without code. In August this year the authors put their code on GitHub, but not the trained network itself. So we are now running their code ourselves on Colab, three times, to see if we also get 63.24 percent. I'll have the numbers next time.</a:t>
+              <a:t>The paper came out without code. In August this year the authors put their code on GitHub, but not the trained network itself. We ran their code ourselves, once so far. It gives 62.71 percent, against their published 63.24: 0.5 points lower. Training behaved like theirs: it stopped by itself at epoch 61, with validation accuracy at 63.6, as in their paper. Half a point is the size of the run-to-run variation we see, so the next two runs will tell us whether this is just that.</a:t>
             </a:r>
             <a:endParaRPr lang="en-US" dirty="0"/>
           </a:p>
@@ -4899,7 +4899,7 @@
         </p:nvSpPr>
         <p:spPr>
           <a:xfrm>
-            <a:off x="6035040" y="1691640"/>
+            <a:off x="6035040" y="1600200"/>
             <a:ext cx="5303520" cy="1005840"/>
           </a:xfrm>
           <a:prstGeom prst="rect">
@@ -4924,7 +4924,7 @@
                 <a:ea typeface="Calibri" pitchFamily="34" charset="-122"/>
                 <a:cs typeface="Calibri" pitchFamily="34" charset="-120"/>
               </a:rPr>
-              <a:t>3 runs</a:t>
+              <a:t>62.71%</a:t>
             </a:r>
             <a:endParaRPr lang="en-US" sz="6000" dirty="0"/>
           </a:p>
@@ -4938,8 +4938,8 @@
         </p:nvSpPr>
         <p:spPr>
           <a:xfrm>
-            <a:off x="6035040" y="2834640"/>
-            <a:ext cx="5394960" cy="1005840"/>
+            <a:off x="6035040" y="2697480"/>
+            <a:ext cx="5394960" cy="822960"/>
           </a:xfrm>
           <a:prstGeom prst="rect">
             <a:avLst/>
@@ -4955,7 +4955,7 @@
               <a:buNone/>
             </a:pPr>
             <a:r>
-              <a:rPr lang="en-US" sz="2100" dirty="0">
+              <a:rPr lang="en-US" sz="1900" dirty="0">
                 <a:solidFill>
                   <a:srgbClr val="FFFFFF"/>
                 </a:solidFill>
@@ -4963,9 +4963,26 @@
                 <a:ea typeface="Calibri" pitchFamily="34" charset="-122"/>
                 <a:cs typeface="Calibri" pitchFamily="34" charset="-120"/>
               </a:rPr>
-              <a:t>of their own code, on Colab now. Do we get 63.24% too?</a:t>
-            </a:r>
-            <a:endParaRPr lang="en-US" sz="2100" dirty="0"/>
+              <a:t>their code, run by us once (more runs going)</a:t>
+            </a:r>
+            <a:endParaRPr lang="en-US" sz="1900" dirty="0"/>
+          </a:p>
+          <a:p>
+            <a:pPr indent="0" marL="0">
+              <a:buNone/>
+            </a:pPr>
+            <a:r>
+              <a:rPr lang="en-US" sz="1900" dirty="0">
+                <a:solidFill>
+                  <a:srgbClr val="FFFFFF"/>
+                </a:solidFill>
+                <a:latin typeface="Calibri" pitchFamily="34" charset="0"/>
+                <a:ea typeface="Calibri" pitchFamily="34" charset="-122"/>
+                <a:cs typeface="Calibri" pitchFamily="34" charset="-120"/>
+              </a:rPr>
+              <a:t>paper: 63.24%</a:t>
+            </a:r>
+            <a:endParaRPr lang="en-US" sz="1900" dirty="0"/>
           </a:p>
         </p:txBody>
       </p:sp>
@@ -5002,7 +5019,7 @@
                 <a:ea typeface="Calibri" pitchFamily="34" charset="-122"/>
                 <a:cs typeface="Calibri" pitchFamily="34" charset="-120"/>
               </a:rPr>
-              <a:t>Now we can run exactly what they ran; results next time.</a:t>
+              <a:t>Their own code, run once: 0.53 points below their paper.</a:t>
             </a:r>
             <a:endParaRPr lang="en-US" sz="2400" dirty="0"/>
           </a:p>

</xml_diff>